<commit_message>
Update frontend labels, backend scripts, PPT templates and tests
</commit_message>
<xml_diff>
--- a/ppt_engine/templates/solution_fixed_modules/公路全封闭声屏障（M1_&_M2）.pptx
+++ b/ppt_engine/templates/solution_fixed_modules/公路全封闭声屏障（M1_&_M2）.pptx
@@ -15,6 +15,7 @@
     <p:sldId id="263" r:id="rId9"/>
     <p:sldId id="264" r:id="rId10"/>
     <p:sldId id="265" r:id="rId11"/>
+    <p:sldId id="266" r:id="rId17"/>
   </p:sldIdLst>
   <p:notesMasterIdLst>
     <p:notesMasterId r:id="rId12"/>
@@ -1818,6 +1819,10 @@
           </a:solidFill>
           <a:ln/>
         </p:spPr>
+        <p:txBody>
+          <a:bodyPr/>
+          <a:p/>
+        </p:txBody>
       </p:sp>
       <p:sp>
         <p:nvSpPr>
@@ -2081,6 +2086,10 @@
           </a:solidFill>
           <a:ln/>
         </p:spPr>
+        <p:txBody>
+          <a:bodyPr/>
+          <a:p/>
+        </p:txBody>
       </p:sp>
       <p:sp>
         <p:nvSpPr>
@@ -2167,6 +2176,458 @@
               <a:t>2026年</a:t>
             </a:r>
             <a:endParaRPr lang="en-US" sz="850" dirty="0"/>
+          </a:p>
+        </p:txBody>
+      </p:sp>
+    </p:spTree>
+  </p:cSld>
+  <p:clrMapOvr>
+    <a:masterClrMapping/>
+  </p:clrMapOvr>
+</p:sld>
+</file>
+
+<file path=ppt/slides/slide11.xml><?xml version="1.0" encoding="utf-8"?>
+<p:sld xmlns:a="http://schemas.openxmlformats.org/drawingml/2006/main" xmlns:p="http://schemas.openxmlformats.org/presentationml/2006/main" xmlns:r="http://schemas.openxmlformats.org/officeDocument/2006/relationships">
+  <p:cSld>
+    <p:bg>
+      <p:bgPr>
+        <a:solidFill>
+          <a:srgbClr val="F7FAFC"/>
+        </a:solidFill>
+        <a:effectLst/>
+      </p:bgPr>
+    </p:bg>
+    <p:spTree>
+      <p:nvGrpSpPr>
+        <p:cNvPr id="1" name=""/>
+        <p:cNvGrpSpPr/>
+        <p:nvPr/>
+      </p:nvGrpSpPr>
+      <p:grpSpPr/>
+      <p:sp>
+        <p:nvSpPr>
+          <p:cNvPr id="2" name="Rectangle 1"/>
+          <p:cNvSpPr/>
+          <p:nvPr/>
+        </p:nvSpPr>
+        <p:spPr>
+          <a:xfrm>
+            <a:off x="0" y="0"/>
+            <a:ext cx="12191695" cy="164592"/>
+          </a:xfrm>
+          <a:prstGeom prst="rect">
+            <a:avLst/>
+          </a:prstGeom>
+          <a:solidFill>
+            <a:srgbClr val="1565C0"/>
+          </a:solidFill>
+          <a:ln>
+            <a:noFill/>
+          </a:ln>
+        </p:spPr>
+        <p:style>
+          <a:lnRef idx="1">
+            <a:schemeClr val="accent1"/>
+          </a:lnRef>
+          <a:fillRef idx="3">
+            <a:schemeClr val="accent1"/>
+          </a:fillRef>
+          <a:effectRef idx="2">
+            <a:schemeClr val="accent1"/>
+          </a:effectRef>
+          <a:fontRef idx="minor">
+            <a:schemeClr val="lt1"/>
+          </a:fontRef>
+        </p:style>
+        <p:txBody>
+          <a:bodyPr rtlCol="0" anchor="ctr"/>
+          <a:lstStyle/>
+          <a:p>
+            <a:pPr algn="ctr"/>
+          </a:p>
+        </p:txBody>
+      </p:sp>
+      <p:sp>
+        <p:nvSpPr>
+          <p:cNvPr id="3" name="TextBox 2"/>
+          <p:cNvSpPr txBox="1"/>
+          <p:nvPr/>
+        </p:nvSpPr>
+        <p:spPr>
+          <a:xfrm>
+            <a:off x="502920" y="320040"/>
+            <a:ext cx="6583680" cy="274320"/>
+          </a:xfrm>
+          <a:prstGeom prst="rect">
+            <a:avLst/>
+          </a:prstGeom>
+          <a:noFill/>
+        </p:spPr>
+        <p:txBody>
+          <a:bodyPr wrap="none">
+            <a:spAutoFit/>
+          </a:bodyPr>
+          <a:lstStyle/>
+          <a:p>
+            <a:r>
+              <a:rPr sz="1200" b="1">
+                <a:solidFill>
+                  <a:srgbClr val="1A3A6B"/>
+                </a:solidFill>
+                <a:latin typeface="Microsoft YaHei"/>
+              </a:rPr>
+              <a:t>中驰智能PPT Demo</a:t>
+            </a:r>
+          </a:p>
+        </p:txBody>
+      </p:sp>
+      <p:sp>
+        <p:nvSpPr>
+          <p:cNvPr id="4" name="TextBox 3"/>
+          <p:cNvSpPr txBox="1"/>
+          <p:nvPr/>
+        </p:nvSpPr>
+        <p:spPr>
+          <a:xfrm>
+            <a:off x="9509760" y="320040"/>
+            <a:ext cx="2103120" cy="274320"/>
+          </a:xfrm>
+          <a:prstGeom prst="rect">
+            <a:avLst/>
+          </a:prstGeom>
+          <a:noFill/>
+        </p:spPr>
+        <p:txBody>
+          <a:bodyPr wrap="none">
+            <a:spAutoFit/>
+          </a:bodyPr>
+          <a:lstStyle/>
+          <a:p>
+            <a:r>
+              <a:rPr sz="1100" b="1">
+                <a:solidFill>
+                  <a:srgbClr val="CA8A04"/>
+                </a:solidFill>
+                <a:latin typeface="Microsoft YaHei"/>
+              </a:rPr>
+              <a:t>M1/M2 | 项目生成信息</a:t>
+            </a:r>
+          </a:p>
+        </p:txBody>
+      </p:sp>
+      <p:sp>
+        <p:nvSpPr>
+          <p:cNvPr id="5" name="TextBox 4"/>
+          <p:cNvSpPr txBox="1"/>
+          <p:nvPr/>
+        </p:nvSpPr>
+        <p:spPr>
+          <a:xfrm>
+            <a:off x="640080" y="640080"/>
+            <a:ext cx="9144000" cy="502920"/>
+          </a:xfrm>
+          <a:prstGeom prst="rect">
+            <a:avLst/>
+          </a:prstGeom>
+          <a:noFill/>
+        </p:spPr>
+        <p:txBody>
+          <a:bodyPr wrap="none">
+            <a:spAutoFit/>
+          </a:bodyPr>
+          <a:lstStyle/>
+          <a:p>
+            <a:r>
+              <a:rPr sz="2600" b="1">
+                <a:solidFill>
+                  <a:srgbClr val="1A3A6B"/>
+                </a:solidFill>
+                <a:latin typeface="Microsoft YaHei"/>
+              </a:rPr>
+              <a:t>项目生成信息</a:t>
+            </a:r>
+          </a:p>
+        </p:txBody>
+      </p:sp>
+      <p:sp>
+        <p:nvSpPr>
+          <p:cNvPr id="6" name="Rectangle 5"/>
+          <p:cNvSpPr/>
+          <p:nvPr/>
+        </p:nvSpPr>
+        <p:spPr>
+          <a:xfrm>
+            <a:off x="640080" y="1234440"/>
+            <a:ext cx="1828800" cy="54864"/>
+          </a:xfrm>
+          <a:prstGeom prst="rect">
+            <a:avLst/>
+          </a:prstGeom>
+          <a:solidFill>
+            <a:srgbClr val="1565C0"/>
+          </a:solidFill>
+          <a:ln>
+            <a:noFill/>
+          </a:ln>
+        </p:spPr>
+        <p:style>
+          <a:lnRef idx="1">
+            <a:schemeClr val="accent1"/>
+          </a:lnRef>
+          <a:fillRef idx="3">
+            <a:schemeClr val="accent1"/>
+          </a:fillRef>
+          <a:effectRef idx="2">
+            <a:schemeClr val="accent1"/>
+          </a:effectRef>
+          <a:fontRef idx="minor">
+            <a:schemeClr val="lt1"/>
+          </a:fontRef>
+        </p:style>
+        <p:txBody>
+          <a:bodyPr rtlCol="0" anchor="ctr"/>
+          <a:lstStyle/>
+          <a:p>
+            <a:pPr algn="ctr"/>
+          </a:p>
+        </p:txBody>
+      </p:sp>
+      <p:sp>
+        <p:nvSpPr>
+          <p:cNvPr id="7" name="TextBox 6"/>
+          <p:cNvSpPr txBox="1"/>
+          <p:nvPr/>
+        </p:nvSpPr>
+        <p:spPr>
+          <a:xfrm>
+            <a:off x="822960" y="1508760"/>
+            <a:ext cx="9601200" cy="411480"/>
+          </a:xfrm>
+          <a:prstGeom prst="rect">
+            <a:avLst/>
+          </a:prstGeom>
+          <a:noFill/>
+        </p:spPr>
+        <p:txBody>
+          <a:bodyPr wrap="none">
+            <a:spAutoFit/>
+          </a:bodyPr>
+          <a:lstStyle/>
+          <a:p>
+            <a:r>
+              <a:rPr sz="1600" b="0">
+                <a:solidFill>
+                  <a:srgbClr val="1F2937"/>
+                </a:solidFill>
+                <a:latin typeface="Microsoft YaHei"/>
+              </a:rPr>
+              <a:t>项目名称：{{project_name}}</a:t>
+            </a:r>
+          </a:p>
+        </p:txBody>
+      </p:sp>
+      <p:sp>
+        <p:nvSpPr>
+          <p:cNvPr id="8" name="TextBox 7"/>
+          <p:cNvSpPr txBox="1"/>
+          <p:nvPr/>
+        </p:nvSpPr>
+        <p:spPr>
+          <a:xfrm>
+            <a:off x="822960" y="2011680"/>
+            <a:ext cx="9601200" cy="411480"/>
+          </a:xfrm>
+          <a:prstGeom prst="rect">
+            <a:avLst/>
+          </a:prstGeom>
+          <a:noFill/>
+        </p:spPr>
+        <p:txBody>
+          <a:bodyPr wrap="none">
+            <a:spAutoFit/>
+          </a:bodyPr>
+          <a:lstStyle/>
+          <a:p>
+            <a:r>
+              <a:rPr sz="1600" b="0">
+                <a:solidFill>
+                  <a:srgbClr val="1F2937"/>
+                </a:solidFill>
+                <a:latin typeface="Microsoft YaHei"/>
+              </a:rPr>
+              <a:t>项目所在地：{{project_location}}</a:t>
+            </a:r>
+          </a:p>
+        </p:txBody>
+      </p:sp>
+      <p:sp>
+        <p:nvSpPr>
+          <p:cNvPr id="9" name="TextBox 8"/>
+          <p:cNvSpPr txBox="1"/>
+          <p:nvPr/>
+        </p:nvSpPr>
+        <p:spPr>
+          <a:xfrm>
+            <a:off x="822960" y="2514600"/>
+            <a:ext cx="9601200" cy="411480"/>
+          </a:xfrm>
+          <a:prstGeom prst="rect">
+            <a:avLst/>
+          </a:prstGeom>
+          <a:noFill/>
+        </p:spPr>
+        <p:txBody>
+          <a:bodyPr wrap="none">
+            <a:spAutoFit/>
+          </a:bodyPr>
+          <a:lstStyle/>
+          <a:p>
+            <a:r>
+              <a:rPr sz="1600" b="0">
+                <a:solidFill>
+                  <a:srgbClr val="1F2937"/>
+                </a:solidFill>
+                <a:latin typeface="Microsoft YaHei"/>
+              </a:rPr>
+              <a:t>建设/业主单位：{{owner_unit}}</a:t>
+            </a:r>
+          </a:p>
+        </p:txBody>
+      </p:sp>
+      <p:sp>
+        <p:nvSpPr>
+          <p:cNvPr id="10" name="TextBox 9"/>
+          <p:cNvSpPr txBox="1"/>
+          <p:nvPr/>
+        </p:nvSpPr>
+        <p:spPr>
+          <a:xfrm>
+            <a:off x="822960" y="3017520"/>
+            <a:ext cx="9601200" cy="411480"/>
+          </a:xfrm>
+          <a:prstGeom prst="rect">
+            <a:avLst/>
+          </a:prstGeom>
+          <a:noFill/>
+        </p:spPr>
+        <p:txBody>
+          <a:bodyPr wrap="none">
+            <a:spAutoFit/>
+          </a:bodyPr>
+          <a:lstStyle/>
+          <a:p>
+            <a:r>
+              <a:rPr sz="1600" b="0">
+                <a:solidFill>
+                  <a:srgbClr val="1F2937"/>
+                </a:solidFill>
+                <a:latin typeface="Microsoft YaHei"/>
+              </a:rPr>
+              <a:t>产品线：{{product_line}}</a:t>
+            </a:r>
+          </a:p>
+        </p:txBody>
+      </p:sp>
+      <p:sp>
+        <p:nvSpPr>
+          <p:cNvPr id="11" name="TextBox 10"/>
+          <p:cNvSpPr txBox="1"/>
+          <p:nvPr/>
+        </p:nvSpPr>
+        <p:spPr>
+          <a:xfrm>
+            <a:off x="822960" y="3520440"/>
+            <a:ext cx="9601200" cy="411480"/>
+          </a:xfrm>
+          <a:prstGeom prst="rect">
+            <a:avLst/>
+          </a:prstGeom>
+          <a:noFill/>
+        </p:spPr>
+        <p:txBody>
+          <a:bodyPr wrap="none">
+            <a:spAutoFit/>
+          </a:bodyPr>
+          <a:lstStyle/>
+          <a:p>
+            <a:r>
+              <a:rPr sz="1600" b="0">
+                <a:solidFill>
+                  <a:srgbClr val="1F2937"/>
+                </a:solidFill>
+                <a:latin typeface="Microsoft YaHei"/>
+              </a:rPr>
+              <a:t>线路名称：{{line_name}}</a:t>
+            </a:r>
+          </a:p>
+        </p:txBody>
+      </p:sp>
+      <p:sp>
+        <p:nvSpPr>
+          <p:cNvPr id="12" name="TextBox 11"/>
+          <p:cNvSpPr txBox="1"/>
+          <p:nvPr/>
+        </p:nvSpPr>
+        <p:spPr>
+          <a:xfrm>
+            <a:off x="822960" y="4023360"/>
+            <a:ext cx="9601200" cy="411480"/>
+          </a:xfrm>
+          <a:prstGeom prst="rect">
+            <a:avLst/>
+          </a:prstGeom>
+          <a:noFill/>
+        </p:spPr>
+        <p:txBody>
+          <a:bodyPr wrap="none">
+            <a:spAutoFit/>
+          </a:bodyPr>
+          <a:lstStyle/>
+          <a:p>
+            <a:r>
+              <a:rPr sz="1600" b="0">
+                <a:solidFill>
+                  <a:srgbClr val="1F2937"/>
+                </a:solidFill>
+                <a:latin typeface="Microsoft YaHei"/>
+              </a:rPr>
+              <a:t>现场痛点：{{site_pain_points}}</a:t>
+            </a:r>
+          </a:p>
+        </p:txBody>
+      </p:sp>
+      <p:sp>
+        <p:nvSpPr>
+          <p:cNvPr id="13" name="TextBox 12"/>
+          <p:cNvSpPr txBox="1"/>
+          <p:nvPr/>
+        </p:nvSpPr>
+        <p:spPr>
+          <a:xfrm>
+            <a:off x="822960" y="4526280"/>
+            <a:ext cx="9601200" cy="411480"/>
+          </a:xfrm>
+          <a:prstGeom prst="rect">
+            <a:avLst/>
+          </a:prstGeom>
+          <a:noFill/>
+        </p:spPr>
+        <p:txBody>
+          <a:bodyPr wrap="none">
+            <a:spAutoFit/>
+          </a:bodyPr>
+          <a:lstStyle/>
+          <a:p>
+            <a:r>
+              <a:rPr sz="1600" b="0">
+                <a:solidFill>
+                  <a:srgbClr val="1F2937"/>
+                </a:solidFill>
+                <a:latin typeface="Microsoft YaHei"/>
+              </a:rPr>
+              <a:t>施工场景：{{construction_scenario}}</a:t>
+            </a:r>
           </a:p>
         </p:txBody>
       </p:sp>
@@ -2344,6 +2805,10 @@
           </a:solidFill>
           <a:ln/>
         </p:spPr>
+        <p:txBody>
+          <a:bodyPr/>
+          <a:p/>
+        </p:txBody>
       </p:sp>
       <p:sp>
         <p:nvSpPr>
@@ -2364,6 +2829,10 @@
           </a:solidFill>
           <a:ln/>
         </p:spPr>
+        <p:txBody>
+          <a:bodyPr/>
+          <a:p/>
+        </p:txBody>
       </p:sp>
       <p:sp>
         <p:nvSpPr>
@@ -2557,6 +3026,10 @@
           </a:solidFill>
           <a:ln/>
         </p:spPr>
+        <p:txBody>
+          <a:bodyPr/>
+          <a:p/>
+        </p:txBody>
       </p:sp>
       <p:sp>
         <p:nvSpPr>
@@ -2577,6 +3050,10 @@
           </a:solidFill>
           <a:ln/>
         </p:spPr>
+        <p:txBody>
+          <a:bodyPr/>
+          <a:p/>
+        </p:txBody>
       </p:sp>
       <p:sp>
         <p:nvSpPr>
@@ -2597,6 +3074,10 @@
           </a:solidFill>
           <a:ln/>
         </p:spPr>
+        <p:txBody>
+          <a:bodyPr/>
+          <a:p/>
+        </p:txBody>
       </p:sp>
       <p:sp>
         <p:nvSpPr>
@@ -2617,6 +3098,10 @@
           </a:solidFill>
           <a:ln/>
         </p:spPr>
+        <p:txBody>
+          <a:bodyPr/>
+          <a:p/>
+        </p:txBody>
       </p:sp>
       <p:sp>
         <p:nvSpPr>
@@ -2637,6 +3122,10 @@
           </a:solidFill>
           <a:ln/>
         </p:spPr>
+        <p:txBody>
+          <a:bodyPr/>
+          <a:p/>
+        </p:txBody>
       </p:sp>
       <p:sp>
         <p:nvSpPr>
@@ -2780,6 +3269,10 @@
           </a:solidFill>
           <a:ln/>
         </p:spPr>
+        <p:txBody>
+          <a:bodyPr/>
+          <a:p/>
+        </p:txBody>
       </p:sp>
       <p:sp>
         <p:nvSpPr>
@@ -2800,6 +3293,10 @@
           </a:solidFill>
           <a:ln/>
         </p:spPr>
+        <p:txBody>
+          <a:bodyPr/>
+          <a:p/>
+        </p:txBody>
       </p:sp>
       <p:sp>
         <p:nvSpPr>
@@ -2820,6 +3317,10 @@
           </a:solidFill>
           <a:ln/>
         </p:spPr>
+        <p:txBody>
+          <a:bodyPr/>
+          <a:p/>
+        </p:txBody>
       </p:sp>
       <p:sp>
         <p:nvSpPr>
@@ -2840,6 +3341,10 @@
           </a:solidFill>
           <a:ln/>
         </p:spPr>
+        <p:txBody>
+          <a:bodyPr/>
+          <a:p/>
+        </p:txBody>
       </p:sp>
       <p:sp>
         <p:nvSpPr>
@@ -2860,6 +3365,10 @@
           </a:solidFill>
           <a:ln/>
         </p:spPr>
+        <p:txBody>
+          <a:bodyPr/>
+          <a:p/>
+        </p:txBody>
       </p:sp>
       <p:sp>
         <p:nvSpPr>
@@ -3003,6 +3512,10 @@
           </a:solidFill>
           <a:ln/>
         </p:spPr>
+        <p:txBody>
+          <a:bodyPr/>
+          <a:p/>
+        </p:txBody>
       </p:sp>
       <p:sp>
         <p:nvSpPr>
@@ -3023,6 +3536,10 @@
           </a:solidFill>
           <a:ln/>
         </p:spPr>
+        <p:txBody>
+          <a:bodyPr/>
+          <a:p/>
+        </p:txBody>
       </p:sp>
       <p:sp>
         <p:nvSpPr>
@@ -3043,6 +3560,10 @@
           </a:solidFill>
           <a:ln/>
         </p:spPr>
+        <p:txBody>
+          <a:bodyPr/>
+          <a:p/>
+        </p:txBody>
       </p:sp>
       <p:sp>
         <p:nvSpPr>
@@ -3063,6 +3584,10 @@
           </a:solidFill>
           <a:ln/>
         </p:spPr>
+        <p:txBody>
+          <a:bodyPr/>
+          <a:p/>
+        </p:txBody>
       </p:sp>
       <p:sp>
         <p:nvSpPr>
@@ -3083,6 +3608,10 @@
           </a:solidFill>
           <a:ln/>
         </p:spPr>
+        <p:txBody>
+          <a:bodyPr/>
+          <a:p/>
+        </p:txBody>
       </p:sp>
       <p:sp>
         <p:nvSpPr>
@@ -3381,6 +3910,10 @@
           </a:solidFill>
           <a:ln/>
         </p:spPr>
+        <p:txBody>
+          <a:bodyPr/>
+          <a:p/>
+        </p:txBody>
       </p:sp>
       <p:sp>
         <p:nvSpPr>
@@ -3401,6 +3934,10 @@
           </a:solidFill>
           <a:ln/>
         </p:spPr>
+        <p:txBody>
+          <a:bodyPr/>
+          <a:p/>
+        </p:txBody>
       </p:sp>
       <p:sp>
         <p:nvSpPr>
@@ -3470,6 +4007,10 @@
             <a:prstDash val="solid"/>
           </a:ln>
         </p:spPr>
+        <p:txBody>
+          <a:bodyPr/>
+          <a:p/>
+        </p:txBody>
       </p:sp>
       <p:sp>
         <p:nvSpPr>
@@ -3536,6 +4077,10 @@
             <a:prstDash val="solid"/>
           </a:ln>
         </p:spPr>
+        <p:txBody>
+          <a:bodyPr/>
+          <a:p/>
+        </p:txBody>
       </p:sp>
       <p:sp>
         <p:nvSpPr>
@@ -3687,6 +4232,10 @@
             <a:prstDash val="solid"/>
           </a:ln>
         </p:spPr>
+        <p:txBody>
+          <a:bodyPr/>
+          <a:p/>
+        </p:txBody>
       </p:sp>
       <p:sp>
         <p:nvSpPr>
@@ -3753,6 +4302,10 @@
             <a:prstDash val="solid"/>
           </a:ln>
         </p:spPr>
+        <p:txBody>
+          <a:bodyPr/>
+          <a:p/>
+        </p:txBody>
       </p:sp>
       <p:sp>
         <p:nvSpPr>
@@ -4156,6 +4709,10 @@
             <a:prstDash val="solid"/>
           </a:ln>
         </p:spPr>
+        <p:txBody>
+          <a:bodyPr/>
+          <a:p/>
+        </p:txBody>
       </p:sp>
       <p:sp>
         <p:nvSpPr>
@@ -4222,6 +4779,10 @@
             <a:prstDash val="solid"/>
           </a:ln>
         </p:spPr>
+        <p:txBody>
+          <a:bodyPr/>
+          <a:p/>
+        </p:txBody>
       </p:sp>
       <p:sp>
         <p:nvSpPr>
@@ -4368,6 +4929,10 @@
           </a:solidFill>
           <a:ln/>
         </p:spPr>
+        <p:txBody>
+          <a:bodyPr/>
+          <a:p/>
+        </p:txBody>
       </p:sp>
       <p:sp>
         <p:nvSpPr>
@@ -4388,6 +4953,10 @@
           </a:solidFill>
           <a:ln/>
         </p:spPr>
+        <p:txBody>
+          <a:bodyPr/>
+          <a:p/>
+        </p:txBody>
       </p:sp>
       <p:sp>
         <p:nvSpPr>
@@ -4408,6 +4977,10 @@
           </a:solidFill>
           <a:ln/>
         </p:spPr>
+        <p:txBody>
+          <a:bodyPr/>
+          <a:p/>
+        </p:txBody>
       </p:sp>
       <p:sp>
         <p:nvSpPr>
@@ -4428,6 +5001,10 @@
           </a:solidFill>
           <a:ln/>
         </p:spPr>
+        <p:txBody>
+          <a:bodyPr/>
+          <a:p/>
+        </p:txBody>
       </p:sp>
       <p:sp>
         <p:nvSpPr>
@@ -4448,6 +5025,10 @@
           </a:solidFill>
           <a:ln/>
         </p:spPr>
+        <p:txBody>
+          <a:bodyPr/>
+          <a:p/>
+        </p:txBody>
       </p:sp>
       <p:sp>
         <p:nvSpPr>
@@ -4711,6 +5292,10 @@
           </a:solidFill>
           <a:ln/>
         </p:spPr>
+        <p:txBody>
+          <a:bodyPr/>
+          <a:p/>
+        </p:txBody>
       </p:sp>
       <p:sp>
         <p:nvSpPr>
@@ -4731,6 +5316,10 @@
           </a:solidFill>
           <a:ln/>
         </p:spPr>
+        <p:txBody>
+          <a:bodyPr/>
+          <a:p/>
+        </p:txBody>
       </p:sp>
       <p:sp>
         <p:nvSpPr>
@@ -4795,6 +5384,10 @@
           </a:solidFill>
           <a:ln/>
         </p:spPr>
+        <p:txBody>
+          <a:bodyPr/>
+          <a:p/>
+        </p:txBody>
       </p:sp>
       <p:sp>
         <p:nvSpPr>
@@ -4815,6 +5408,10 @@
           </a:solidFill>
           <a:ln/>
         </p:spPr>
+        <p:txBody>
+          <a:bodyPr/>
+          <a:p/>
+        </p:txBody>
       </p:sp>
       <p:sp>
         <p:nvSpPr>
@@ -4835,6 +5432,10 @@
           </a:solidFill>
           <a:ln/>
         </p:spPr>
+        <p:txBody>
+          <a:bodyPr/>
+          <a:p/>
+        </p:txBody>
       </p:sp>
       <p:sp>
         <p:nvSpPr>
@@ -4855,6 +5456,10 @@
           </a:solidFill>
           <a:ln/>
         </p:spPr>
+        <p:txBody>
+          <a:bodyPr/>
+          <a:p/>
+        </p:txBody>
       </p:sp>
       <p:sp>
         <p:nvSpPr>
@@ -4875,6 +5480,10 @@
           </a:solidFill>
           <a:ln/>
         </p:spPr>
+        <p:txBody>
+          <a:bodyPr/>
+          <a:p/>
+        </p:txBody>
       </p:sp>
       <p:sp>
         <p:nvSpPr>
@@ -4895,6 +5504,10 @@
           </a:solidFill>
           <a:ln/>
         </p:spPr>
+        <p:txBody>
+          <a:bodyPr/>
+          <a:p/>
+        </p:txBody>
       </p:sp>
       <p:pic>
         <p:nvPicPr>
@@ -5296,6 +5909,10 @@
           </a:solidFill>
           <a:ln/>
         </p:spPr>
+        <p:txBody>
+          <a:bodyPr/>
+          <a:p/>
+        </p:txBody>
       </p:sp>
       <p:sp>
         <p:nvSpPr>
@@ -5316,6 +5933,10 @@
           </a:solidFill>
           <a:ln/>
         </p:spPr>
+        <p:txBody>
+          <a:bodyPr/>
+          <a:p/>
+        </p:txBody>
       </p:sp>
       <p:sp>
         <p:nvSpPr>
@@ -5336,6 +5957,10 @@
           </a:solidFill>
           <a:ln/>
         </p:spPr>
+        <p:txBody>
+          <a:bodyPr/>
+          <a:p/>
+        </p:txBody>
       </p:sp>
       <p:sp>
         <p:nvSpPr>
@@ -5356,6 +5981,10 @@
           </a:solidFill>
           <a:ln/>
         </p:spPr>
+        <p:txBody>
+          <a:bodyPr/>
+          <a:p/>
+        </p:txBody>
       </p:sp>
       <p:sp>
         <p:nvSpPr>
@@ -5376,6 +6005,10 @@
           </a:solidFill>
           <a:ln/>
         </p:spPr>
+        <p:txBody>
+          <a:bodyPr/>
+          <a:p/>
+        </p:txBody>
       </p:sp>
       <p:sp>
         <p:nvSpPr>
@@ -5396,6 +6029,10 @@
           </a:solidFill>
           <a:ln/>
         </p:spPr>
+        <p:txBody>
+          <a:bodyPr/>
+          <a:p/>
+        </p:txBody>
       </p:sp>
       <p:pic>
         <p:nvPicPr>
@@ -5551,6 +6188,10 @@
           </a:solidFill>
           <a:ln/>
         </p:spPr>
+        <p:txBody>
+          <a:bodyPr/>
+          <a:p/>
+        </p:txBody>
       </p:sp>
       <p:sp>
         <p:nvSpPr>
@@ -5571,6 +6212,10 @@
           </a:solidFill>
           <a:ln/>
         </p:spPr>
+        <p:txBody>
+          <a:bodyPr/>
+          <a:p/>
+        </p:txBody>
       </p:sp>
       <p:sp>
         <p:nvSpPr>
@@ -5679,6 +6324,10 @@
           </a:solidFill>
           <a:ln/>
         </p:spPr>
+        <p:txBody>
+          <a:bodyPr/>
+          <a:p/>
+        </p:txBody>
       </p:sp>
       <p:sp>
         <p:nvSpPr>
@@ -5699,6 +6348,10 @@
           </a:solidFill>
           <a:ln/>
         </p:spPr>
+        <p:txBody>
+          <a:bodyPr/>
+          <a:p/>
+        </p:txBody>
       </p:sp>
       <p:sp>
         <p:nvSpPr>
@@ -5719,6 +6372,10 @@
           </a:solidFill>
           <a:ln/>
         </p:spPr>
+        <p:txBody>
+          <a:bodyPr/>
+          <a:p/>
+        </p:txBody>
       </p:sp>
       <p:sp>
         <p:nvSpPr>
@@ -5739,6 +6396,10 @@
           </a:solidFill>
           <a:ln/>
         </p:spPr>
+        <p:txBody>
+          <a:bodyPr/>
+          <a:p/>
+        </p:txBody>
       </p:sp>
       <p:sp>
         <p:nvSpPr>
@@ -5759,6 +6420,10 @@
           </a:solidFill>
           <a:ln/>
         </p:spPr>
+        <p:txBody>
+          <a:bodyPr/>
+          <a:p/>
+        </p:txBody>
       </p:sp>
       <p:sp>
         <p:nvSpPr>
@@ -5779,6 +6444,10 @@
           </a:solidFill>
           <a:ln/>
         </p:spPr>
+        <p:txBody>
+          <a:bodyPr/>
+          <a:p/>
+        </p:txBody>
       </p:sp>
       <p:pic>
         <p:nvPicPr>
@@ -6098,6 +6767,10 @@
           </a:solidFill>
           <a:ln/>
         </p:spPr>
+        <p:txBody>
+          <a:bodyPr/>
+          <a:p/>
+        </p:txBody>
       </p:sp>
       <p:sp>
         <p:nvSpPr>
@@ -6118,6 +6791,10 @@
           </a:solidFill>
           <a:ln/>
         </p:spPr>
+        <p:txBody>
+          <a:bodyPr/>
+          <a:p/>
+        </p:txBody>
       </p:sp>
       <p:sp>
         <p:nvSpPr>
@@ -6370,6 +7047,10 @@
           </a:solidFill>
           <a:ln/>
         </p:spPr>
+        <p:txBody>
+          <a:bodyPr/>
+          <a:p/>
+        </p:txBody>
       </p:sp>
       <p:sp>
         <p:nvSpPr>
@@ -6390,6 +7071,10 @@
           </a:solidFill>
           <a:ln/>
         </p:spPr>
+        <p:txBody>
+          <a:bodyPr/>
+          <a:p/>
+        </p:txBody>
       </p:sp>
       <p:sp>
         <p:nvSpPr>
@@ -6500,6 +7185,10 @@
             <a:prstDash val="solid"/>
           </a:ln>
         </p:spPr>
+        <p:txBody>
+          <a:bodyPr/>
+          <a:p/>
+        </p:txBody>
       </p:sp>
       <p:sp>
         <p:nvSpPr>
@@ -6566,6 +7255,10 @@
             <a:prstDash val="solid"/>
           </a:ln>
         </p:spPr>
+        <p:txBody>
+          <a:bodyPr/>
+          <a:p/>
+        </p:txBody>
       </p:sp>
       <p:sp>
         <p:nvSpPr>
@@ -6632,6 +7325,10 @@
             <a:prstDash val="solid"/>
           </a:ln>
         </p:spPr>
+        <p:txBody>
+          <a:bodyPr/>
+          <a:p/>
+        </p:txBody>
       </p:sp>
       <p:sp>
         <p:nvSpPr>
@@ -6816,6 +7513,10 @@
           </a:solidFill>
           <a:ln/>
         </p:spPr>
+        <p:txBody>
+          <a:bodyPr/>
+          <a:p/>
+        </p:txBody>
       </p:sp>
       <p:sp>
         <p:nvSpPr>
@@ -7082,6 +7783,10 @@
           </a:solidFill>
           <a:ln/>
         </p:spPr>
+        <p:txBody>
+          <a:bodyPr/>
+          <a:p/>
+        </p:txBody>
       </p:sp>
       <p:sp>
         <p:nvSpPr>
@@ -7348,6 +8053,10 @@
           </a:solidFill>
           <a:ln/>
         </p:spPr>
+        <p:txBody>
+          <a:bodyPr/>
+          <a:p/>
+        </p:txBody>
       </p:sp>
       <p:sp>
         <p:nvSpPr>
@@ -7614,6 +8323,10 @@
           </a:solidFill>
           <a:ln/>
         </p:spPr>
+        <p:txBody>
+          <a:bodyPr/>
+          <a:p/>
+        </p:txBody>
       </p:sp>
       <p:sp>
         <p:nvSpPr>
@@ -7921,6 +8634,10 @@
           </a:solidFill>
           <a:ln/>
         </p:spPr>
+        <p:txBody>
+          <a:bodyPr/>
+          <a:p/>
+        </p:txBody>
       </p:sp>
       <p:sp>
         <p:nvSpPr>
@@ -7941,6 +8658,10 @@
           </a:solidFill>
           <a:ln/>
         </p:spPr>
+        <p:txBody>
+          <a:bodyPr/>
+          <a:p/>
+        </p:txBody>
       </p:sp>
       <p:sp>
         <p:nvSpPr>
@@ -7961,6 +8682,10 @@
           </a:solidFill>
           <a:ln/>
         </p:spPr>
+        <p:txBody>
+          <a:bodyPr/>
+          <a:p/>
+        </p:txBody>
       </p:sp>
       <p:sp>
         <p:nvSpPr>
@@ -7981,6 +8706,10 @@
           </a:solidFill>
           <a:ln/>
         </p:spPr>
+        <p:txBody>
+          <a:bodyPr/>
+          <a:p/>
+        </p:txBody>
       </p:sp>
       <p:sp>
         <p:nvSpPr>
@@ -8001,6 +8730,10 @@
           </a:solidFill>
           <a:ln/>
         </p:spPr>
+        <p:txBody>
+          <a:bodyPr/>
+          <a:p/>
+        </p:txBody>
       </p:sp>
       <p:sp>
         <p:nvSpPr>
@@ -8147,6 +8880,10 @@
           </a:solidFill>
           <a:ln/>
         </p:spPr>
+        <p:txBody>
+          <a:bodyPr/>
+          <a:p/>
+        </p:txBody>
       </p:sp>
       <p:sp>
         <p:nvSpPr>
@@ -8167,6 +8904,10 @@
           </a:solidFill>
           <a:ln/>
         </p:spPr>
+        <p:txBody>
+          <a:bodyPr/>
+          <a:p/>
+        </p:txBody>
       </p:sp>
       <p:sp>
         <p:nvSpPr>
@@ -8187,6 +8928,10 @@
           </a:solidFill>
           <a:ln/>
         </p:spPr>
+        <p:txBody>
+          <a:bodyPr/>
+          <a:p/>
+        </p:txBody>
       </p:sp>
       <p:sp>
         <p:nvSpPr>
@@ -8207,6 +8952,10 @@
           </a:solidFill>
           <a:ln/>
         </p:spPr>
+        <p:txBody>
+          <a:bodyPr/>
+          <a:p/>
+        </p:txBody>
       </p:sp>
       <p:sp>
         <p:nvSpPr>
@@ -8227,6 +8976,10 @@
           </a:solidFill>
           <a:ln/>
         </p:spPr>
+        <p:txBody>
+          <a:bodyPr/>
+          <a:p/>
+        </p:txBody>
       </p:sp>
       <p:sp>
         <p:nvSpPr>
@@ -8528,6 +9281,10 @@
           </a:solidFill>
           <a:ln/>
         </p:spPr>
+        <p:txBody>
+          <a:bodyPr/>
+          <a:p/>
+        </p:txBody>
       </p:sp>
       <p:sp>
         <p:nvSpPr>
@@ -8548,6 +9305,10 @@
           </a:solidFill>
           <a:ln/>
         </p:spPr>
+        <p:txBody>
+          <a:bodyPr/>
+          <a:p/>
+        </p:txBody>
       </p:sp>
       <p:sp>
         <p:nvSpPr>
@@ -8658,6 +9419,10 @@
             <a:prstDash val="solid"/>
           </a:ln>
         </p:spPr>
+        <p:txBody>
+          <a:bodyPr/>
+          <a:p/>
+        </p:txBody>
       </p:sp>
       <p:sp>
         <p:nvSpPr>
@@ -8724,6 +9489,10 @@
             <a:prstDash val="solid"/>
           </a:ln>
         </p:spPr>
+        <p:txBody>
+          <a:bodyPr/>
+          <a:p/>
+        </p:txBody>
       </p:sp>
       <p:sp>
         <p:nvSpPr>
@@ -8790,6 +9559,10 @@
             <a:prstDash val="solid"/>
           </a:ln>
         </p:spPr>
+        <p:txBody>
+          <a:bodyPr/>
+          <a:p/>
+        </p:txBody>
       </p:sp>
       <p:sp>
         <p:nvSpPr>
@@ -8856,6 +9629,10 @@
             <a:prstDash val="solid"/>
           </a:ln>
         </p:spPr>
+        <p:txBody>
+          <a:bodyPr/>
+          <a:p/>
+        </p:txBody>
       </p:sp>
       <p:sp>
         <p:nvSpPr>
@@ -9093,6 +9870,10 @@
           </a:solidFill>
           <a:ln/>
         </p:spPr>
+        <p:txBody>
+          <a:bodyPr/>
+          <a:p/>
+        </p:txBody>
       </p:sp>
       <p:sp>
         <p:nvSpPr>
@@ -9465,6 +10246,10 @@
           </a:solidFill>
           <a:ln/>
         </p:spPr>
+        <p:txBody>
+          <a:bodyPr/>
+          <a:p/>
+        </p:txBody>
       </p:sp>
       <p:sp>
         <p:nvSpPr>
@@ -9837,6 +10622,10 @@
           </a:solidFill>
           <a:ln/>
         </p:spPr>
+        <p:txBody>
+          <a:bodyPr/>
+          <a:p/>
+        </p:txBody>
       </p:sp>
       <p:sp>
         <p:nvSpPr>
@@ -10033,6 +10822,10 @@
           </a:solidFill>
           <a:ln/>
         </p:spPr>
+        <p:txBody>
+          <a:bodyPr/>
+          <a:p/>
+        </p:txBody>
       </p:sp>
       <p:sp>
         <p:nvSpPr>
@@ -10053,6 +10846,10 @@
           </a:solidFill>
           <a:ln/>
         </p:spPr>
+        <p:txBody>
+          <a:bodyPr/>
+          <a:p/>
+        </p:txBody>
       </p:sp>
       <p:sp>
         <p:nvSpPr>
@@ -10073,6 +10870,10 @@
           </a:solidFill>
           <a:ln/>
         </p:spPr>
+        <p:txBody>
+          <a:bodyPr/>
+          <a:p/>
+        </p:txBody>
       </p:sp>
       <p:sp>
         <p:nvSpPr>
@@ -10093,6 +10894,10 @@
           </a:solidFill>
           <a:ln/>
         </p:spPr>
+        <p:txBody>
+          <a:bodyPr/>
+          <a:p/>
+        </p:txBody>
       </p:sp>
       <p:sp>
         <p:nvSpPr>
@@ -10113,6 +10918,10 @@
           </a:solidFill>
           <a:ln/>
         </p:spPr>
+        <p:txBody>
+          <a:bodyPr/>
+          <a:p/>
+        </p:txBody>
       </p:sp>
       <p:sp>
         <p:nvSpPr>
@@ -10174,6 +10983,10 @@
           </a:solidFill>
           <a:ln/>
         </p:spPr>
+        <p:txBody>
+          <a:bodyPr/>
+          <a:p/>
+        </p:txBody>
       </p:sp>
       <p:sp>
         <p:nvSpPr>
@@ -10301,6 +11114,10 @@
           </a:solidFill>
           <a:ln/>
         </p:spPr>
+        <p:txBody>
+          <a:bodyPr/>
+          <a:p/>
+        </p:txBody>
       </p:sp>
       <p:sp>
         <p:nvSpPr>
@@ -10428,6 +11245,10 @@
           </a:solidFill>
           <a:ln/>
         </p:spPr>
+        <p:txBody>
+          <a:bodyPr/>
+          <a:p/>
+        </p:txBody>
       </p:sp>
       <p:sp>
         <p:nvSpPr>
@@ -10555,6 +11376,10 @@
           </a:solidFill>
           <a:ln/>
         </p:spPr>
+        <p:txBody>
+          <a:bodyPr/>
+          <a:p/>
+        </p:txBody>
       </p:sp>
       <p:sp>
         <p:nvSpPr>
@@ -10771,6 +11596,10 @@
           </a:solidFill>
           <a:ln/>
         </p:spPr>
+        <p:txBody>
+          <a:bodyPr/>
+          <a:p/>
+        </p:txBody>
       </p:sp>
       <p:sp>
         <p:nvSpPr>
@@ -10791,6 +11620,10 @@
           </a:solidFill>
           <a:ln/>
         </p:spPr>
+        <p:txBody>
+          <a:bodyPr/>
+          <a:p/>
+        </p:txBody>
       </p:sp>
       <p:sp>
         <p:nvSpPr>
@@ -10855,6 +11688,10 @@
           </a:solidFill>
           <a:ln/>
         </p:spPr>
+        <p:txBody>
+          <a:bodyPr/>
+          <a:p/>
+        </p:txBody>
       </p:sp>
       <p:sp>
         <p:nvSpPr>
@@ -10875,6 +11712,10 @@
           </a:solidFill>
           <a:ln/>
         </p:spPr>
+        <p:txBody>
+          <a:bodyPr/>
+          <a:p/>
+        </p:txBody>
       </p:sp>
       <p:sp>
         <p:nvSpPr>
@@ -10895,6 +11736,10 @@
           </a:solidFill>
           <a:ln/>
         </p:spPr>
+        <p:txBody>
+          <a:bodyPr/>
+          <a:p/>
+        </p:txBody>
       </p:sp>
       <p:sp>
         <p:nvSpPr>
@@ -10915,6 +11760,10 @@
           </a:solidFill>
           <a:ln/>
         </p:spPr>
+        <p:txBody>
+          <a:bodyPr/>
+          <a:p/>
+        </p:txBody>
       </p:sp>
       <p:sp>
         <p:nvSpPr>
@@ -10935,6 +11784,10 @@
           </a:solidFill>
           <a:ln/>
         </p:spPr>
+        <p:txBody>
+          <a:bodyPr/>
+          <a:p/>
+        </p:txBody>
       </p:sp>
       <p:pic>
         <p:nvPicPr>
@@ -11223,6 +12076,10 @@
             <a:prstDash val="solid"/>
           </a:ln>
         </p:spPr>
+        <p:txBody>
+          <a:bodyPr/>
+          <a:p/>
+        </p:txBody>
       </p:sp>
       <p:sp>
         <p:nvSpPr>
@@ -11289,6 +12146,10 @@
             <a:prstDash val="solid"/>
           </a:ln>
         </p:spPr>
+        <p:txBody>
+          <a:bodyPr/>
+          <a:p/>
+        </p:txBody>
       </p:sp>
       <p:sp>
         <p:nvSpPr>
@@ -11355,6 +12216,10 @@
             <a:prstDash val="solid"/>
           </a:ln>
         </p:spPr>
+        <p:txBody>
+          <a:bodyPr/>
+          <a:p/>
+        </p:txBody>
       </p:sp>
       <p:sp>
         <p:nvSpPr>
@@ -11421,6 +12286,10 @@
             <a:prstDash val="solid"/>
           </a:ln>
         </p:spPr>
+        <p:txBody>
+          <a:bodyPr/>
+          <a:p/>
+        </p:txBody>
       </p:sp>
       <p:sp>
         <p:nvSpPr>
@@ -11682,6 +12551,10 @@
           </a:solidFill>
           <a:ln/>
         </p:spPr>
+        <p:txBody>
+          <a:bodyPr/>
+          <a:p/>
+        </p:txBody>
       </p:sp>
       <p:sp>
         <p:nvSpPr>
@@ -12107,6 +12980,10 @@
             <a:prstDash val="solid"/>
           </a:ln>
         </p:spPr>
+        <p:txBody>
+          <a:bodyPr/>
+          <a:p/>
+        </p:txBody>
       </p:sp>
       <p:pic>
         <p:nvPicPr>
@@ -12435,6 +13312,10 @@
           </a:solidFill>
           <a:ln/>
         </p:spPr>
+        <p:txBody>
+          <a:bodyPr/>
+          <a:p/>
+        </p:txBody>
       </p:sp>
       <p:sp>
         <p:nvSpPr>
@@ -12455,6 +13336,10 @@
           </a:solidFill>
           <a:ln/>
         </p:spPr>
+        <p:txBody>
+          <a:bodyPr/>
+          <a:p/>
+        </p:txBody>
       </p:sp>
       <p:sp>
         <p:nvSpPr>
@@ -12584,6 +13469,10 @@
           </a:solidFill>
           <a:ln/>
         </p:spPr>
+        <p:txBody>
+          <a:bodyPr/>
+          <a:p/>
+        </p:txBody>
       </p:sp>
       <p:sp>
         <p:nvSpPr>
@@ -12604,6 +13493,10 @@
           </a:solidFill>
           <a:ln/>
         </p:spPr>
+        <p:txBody>
+          <a:bodyPr/>
+          <a:p/>
+        </p:txBody>
       </p:sp>
       <p:sp>
         <p:nvSpPr>
@@ -12624,6 +13517,10 @@
           </a:solidFill>
           <a:ln/>
         </p:spPr>
+        <p:txBody>
+          <a:bodyPr/>
+          <a:p/>
+        </p:txBody>
       </p:sp>
       <p:sp>
         <p:nvSpPr>
@@ -12644,6 +13541,10 @@
           </a:solidFill>
           <a:ln/>
         </p:spPr>
+        <p:txBody>
+          <a:bodyPr/>
+          <a:p/>
+        </p:txBody>
       </p:sp>
       <p:sp>
         <p:nvSpPr>
@@ -12664,6 +13565,10 @@
           </a:solidFill>
           <a:ln/>
         </p:spPr>
+        <p:txBody>
+          <a:bodyPr/>
+          <a:p/>
+        </p:txBody>
       </p:sp>
       <p:pic>
         <p:nvPicPr>
@@ -12793,6 +13698,10 @@
           </a:solidFill>
           <a:ln/>
         </p:spPr>
+        <p:txBody>
+          <a:bodyPr/>
+          <a:p/>
+        </p:txBody>
       </p:sp>
       <p:sp>
         <p:nvSpPr>
@@ -12813,6 +13722,10 @@
           </a:solidFill>
           <a:ln/>
         </p:spPr>
+        <p:txBody>
+          <a:bodyPr/>
+          <a:p/>
+        </p:txBody>
       </p:sp>
       <p:sp>
         <p:nvSpPr>
@@ -12833,6 +13746,10 @@
           </a:solidFill>
           <a:ln/>
         </p:spPr>
+        <p:txBody>
+          <a:bodyPr/>
+          <a:p/>
+        </p:txBody>
       </p:sp>
       <p:sp>
         <p:nvSpPr>
@@ -12853,6 +13770,10 @@
           </a:solidFill>
           <a:ln/>
         </p:spPr>
+        <p:txBody>
+          <a:bodyPr/>
+          <a:p/>
+        </p:txBody>
       </p:sp>
       <p:sp>
         <p:nvSpPr>
@@ -12873,6 +13794,10 @@
           </a:solidFill>
           <a:ln/>
         </p:spPr>
+        <p:txBody>
+          <a:bodyPr/>
+          <a:p/>
+        </p:txBody>
       </p:sp>
       <p:pic>
         <p:nvPicPr>
@@ -13002,6 +13927,10 @@
           </a:solidFill>
           <a:ln/>
         </p:spPr>
+        <p:txBody>
+          <a:bodyPr/>
+          <a:p/>
+        </p:txBody>
       </p:sp>
       <p:sp>
         <p:nvSpPr>
@@ -13022,6 +13951,10 @@
           </a:solidFill>
           <a:ln/>
         </p:spPr>
+        <p:txBody>
+          <a:bodyPr/>
+          <a:p/>
+        </p:txBody>
       </p:sp>
       <p:sp>
         <p:nvSpPr>
@@ -13042,6 +13975,10 @@
           </a:solidFill>
           <a:ln/>
         </p:spPr>
+        <p:txBody>
+          <a:bodyPr/>
+          <a:p/>
+        </p:txBody>
       </p:sp>
       <p:sp>
         <p:nvSpPr>
@@ -13062,6 +13999,10 @@
           </a:solidFill>
           <a:ln/>
         </p:spPr>
+        <p:txBody>
+          <a:bodyPr/>
+          <a:p/>
+        </p:txBody>
       </p:sp>
       <p:sp>
         <p:nvSpPr>
@@ -13082,6 +14023,10 @@
           </a:solidFill>
           <a:ln/>
         </p:spPr>
+        <p:txBody>
+          <a:bodyPr/>
+          <a:p/>
+        </p:txBody>
       </p:sp>
       <p:sp>
         <p:nvSpPr>
@@ -13252,6 +14197,10 @@
           </a:solidFill>
           <a:ln/>
         </p:spPr>
+        <p:txBody>
+          <a:bodyPr/>
+          <a:p/>
+        </p:txBody>
       </p:sp>
       <p:sp>
         <p:nvSpPr>
@@ -13272,6 +14221,10 @@
           </a:solidFill>
           <a:ln/>
         </p:spPr>
+        <p:txBody>
+          <a:bodyPr/>
+          <a:p/>
+        </p:txBody>
       </p:sp>
       <p:sp>
         <p:nvSpPr>
@@ -13292,6 +14245,10 @@
           </a:solidFill>
           <a:ln/>
         </p:spPr>
+        <p:txBody>
+          <a:bodyPr/>
+          <a:p/>
+        </p:txBody>
       </p:sp>
       <p:sp>
         <p:nvSpPr>
@@ -13312,6 +14269,10 @@
           </a:solidFill>
           <a:ln/>
         </p:spPr>
+        <p:txBody>
+          <a:bodyPr/>
+          <a:p/>
+        </p:txBody>
       </p:sp>
       <p:sp>
         <p:nvSpPr>
@@ -13332,6 +14293,10 @@
           </a:solidFill>
           <a:ln/>
         </p:spPr>
+        <p:txBody>
+          <a:bodyPr/>
+          <a:p/>
+        </p:txBody>
       </p:sp>
       <p:pic>
         <p:nvPicPr>
@@ -13640,6 +14605,10 @@
           </a:solidFill>
           <a:ln/>
         </p:spPr>
+        <p:txBody>
+          <a:bodyPr/>
+          <a:p/>
+        </p:txBody>
       </p:sp>
       <p:sp>
         <p:nvSpPr>
@@ -13660,6 +14629,10 @@
           </a:solidFill>
           <a:ln/>
         </p:spPr>
+        <p:txBody>
+          <a:bodyPr/>
+          <a:p/>
+        </p:txBody>
       </p:sp>
       <p:sp>
         <p:nvSpPr>
@@ -13794,6 +14767,10 @@
             <a:prstDash val="solid"/>
           </a:ln>
         </p:spPr>
+        <p:txBody>
+          <a:bodyPr/>
+          <a:p/>
+        </p:txBody>
       </p:sp>
       <p:sp>
         <p:nvSpPr>
@@ -13860,6 +14837,10 @@
             <a:prstDash val="solid"/>
           </a:ln>
         </p:spPr>
+        <p:txBody>
+          <a:bodyPr/>
+          <a:p/>
+        </p:txBody>
       </p:sp>
       <p:sp>
         <p:nvSpPr>
@@ -13926,6 +14907,10 @@
             <a:prstDash val="solid"/>
           </a:ln>
         </p:spPr>
+        <p:txBody>
+          <a:bodyPr/>
+          <a:p/>
+        </p:txBody>
       </p:sp>
       <p:sp>
         <p:nvSpPr>
@@ -13992,6 +14977,10 @@
             <a:prstDash val="solid"/>
           </a:ln>
         </p:spPr>
+        <p:txBody>
+          <a:bodyPr/>
+          <a:p/>
+        </p:txBody>
       </p:sp>
       <p:sp>
         <p:nvSpPr>
@@ -14229,6 +15218,10 @@
           </a:solidFill>
           <a:ln/>
         </p:spPr>
+        <p:txBody>
+          <a:bodyPr/>
+          <a:p/>
+        </p:txBody>
       </p:sp>
       <p:sp>
         <p:nvSpPr>
@@ -14666,6 +15659,10 @@
           </a:solidFill>
           <a:ln/>
         </p:spPr>
+        <p:txBody>
+          <a:bodyPr/>
+          <a:p/>
+        </p:txBody>
       </p:sp>
       <p:sp>
         <p:nvSpPr>
@@ -14686,6 +15683,10 @@
           </a:solidFill>
           <a:ln/>
         </p:spPr>
+        <p:txBody>
+          <a:bodyPr/>
+          <a:p/>
+        </p:txBody>
       </p:sp>
       <p:sp>
         <p:nvSpPr>
@@ -14706,6 +15707,10 @@
           </a:solidFill>
           <a:ln/>
         </p:spPr>
+        <p:txBody>
+          <a:bodyPr/>
+          <a:p/>
+        </p:txBody>
       </p:sp>
       <p:sp>
         <p:nvSpPr>
@@ -14726,6 +15731,10 @@
           </a:solidFill>
           <a:ln/>
         </p:spPr>
+        <p:txBody>
+          <a:bodyPr/>
+          <a:p/>
+        </p:txBody>
       </p:sp>
       <p:sp>
         <p:nvSpPr>
@@ -14746,6 +15755,10 @@
           </a:solidFill>
           <a:ln/>
         </p:spPr>
+        <p:txBody>
+          <a:bodyPr/>
+          <a:p/>
+        </p:txBody>
       </p:sp>
       <p:sp>
         <p:nvSpPr>
@@ -14851,6 +15864,10 @@
           </a:solidFill>
           <a:ln/>
         </p:spPr>
+        <p:txBody>
+          <a:bodyPr/>
+          <a:p/>
+        </p:txBody>
       </p:sp>
       <p:sp>
         <p:nvSpPr>
@@ -14871,6 +15888,10 @@
           </a:solidFill>
           <a:ln/>
         </p:spPr>
+        <p:txBody>
+          <a:bodyPr/>
+          <a:p/>
+        </p:txBody>
       </p:sp>
       <p:sp>
         <p:nvSpPr>
@@ -14891,6 +15912,10 @@
           </a:solidFill>
           <a:ln/>
         </p:spPr>
+        <p:txBody>
+          <a:bodyPr/>
+          <a:p/>
+        </p:txBody>
       </p:sp>
       <p:sp>
         <p:nvSpPr>
@@ -14911,6 +15936,10 @@
           </a:solidFill>
           <a:ln/>
         </p:spPr>
+        <p:txBody>
+          <a:bodyPr/>
+          <a:p/>
+        </p:txBody>
       </p:sp>
       <p:sp>
         <p:nvSpPr>
@@ -14931,6 +15960,10 @@
           </a:solidFill>
           <a:ln/>
         </p:spPr>
+        <p:txBody>
+          <a:bodyPr/>
+          <a:p/>
+        </p:txBody>
       </p:sp>
       <p:sp>
         <p:nvSpPr>
@@ -15036,6 +16069,10 @@
           </a:solidFill>
           <a:ln/>
         </p:spPr>
+        <p:txBody>
+          <a:bodyPr/>
+          <a:p/>
+        </p:txBody>
       </p:sp>
       <p:sp>
         <p:nvSpPr>
@@ -15056,6 +16093,10 @@
           </a:solidFill>
           <a:ln/>
         </p:spPr>
+        <p:txBody>
+          <a:bodyPr/>
+          <a:p/>
+        </p:txBody>
       </p:sp>
       <p:sp>
         <p:nvSpPr>
@@ -15076,6 +16117,10 @@
           </a:solidFill>
           <a:ln/>
         </p:spPr>
+        <p:txBody>
+          <a:bodyPr/>
+          <a:p/>
+        </p:txBody>
       </p:sp>
       <p:sp>
         <p:nvSpPr>
@@ -15096,6 +16141,10 @@
           </a:solidFill>
           <a:ln/>
         </p:spPr>
+        <p:txBody>
+          <a:bodyPr/>
+          <a:p/>
+        </p:txBody>
       </p:sp>
       <p:sp>
         <p:nvSpPr>
@@ -15116,6 +16165,10 @@
           </a:solidFill>
           <a:ln/>
         </p:spPr>
+        <p:txBody>
+          <a:bodyPr/>
+          <a:p/>
+        </p:txBody>
       </p:sp>
       <p:sp>
         <p:nvSpPr>
@@ -15221,6 +16274,10 @@
           </a:solidFill>
           <a:ln/>
         </p:spPr>
+        <p:txBody>
+          <a:bodyPr/>
+          <a:p/>
+        </p:txBody>
       </p:sp>
       <p:sp>
         <p:nvSpPr>

</xml_diff>